<commit_message>
feat: adiciona definicoes de acronimos no rodape dos slides (ETHAGT01-16)
Para cada apresentacao ETHAGT01 a ETHAGT16:
- Modificado gerar_pptx.py: add_footer e funcoes de slide aceitam parametro acronyms
- Definicoes de acronimos especificos do dominio agentic AI/LLM no rodape
- Apenas na primeira aparicao de cada acronimo na apresentacao
- Markdown slides-detalhados atualizados com campo Rodape
- Todos os PPTX regenerados (~1000 slides totais, ~110 acronimos definidos)
</commit_message>
<xml_diff>
--- a/03-Slides/ETHAGT01/ETHAGT01-Apresentacao.pptx
+++ b/03-Slides/ETHAGT01/ETHAGT01-Apresentacao.pptx
@@ -8724,6 +8724,42 @@
           </a:p>
         </p:txBody>
       </p:sp>
+      <p:sp>
+        <p:nvSpPr>
+          <p:cNvPr id="5" name="TextBox 4"/>
+          <p:cNvSpPr txBox="1"/>
+          <p:nvPr/>
+        </p:nvSpPr>
+        <p:spPr>
+          <a:xfrm>
+            <a:off x="914400" y="5943600"/>
+            <a:ext cx="10058400" cy="365760"/>
+          </a:xfrm>
+          <a:prstGeom prst="rect">
+            <a:avLst/>
+          </a:prstGeom>
+          <a:noFill/>
+        </p:spPr>
+        <p:txBody>
+          <a:bodyPr wrap="square">
+            <a:spAutoFit/>
+          </a:bodyPr>
+          <a:lstStyle/>
+          <a:p>
+            <a:pPr algn="ctr">
+              <a:defRPr sz="1100" b="0">
+                <a:solidFill>
+                  <a:srgbClr val="6B7A8F"/>
+                </a:solidFill>
+                <a:latin typeface="Segoe UI"/>
+              </a:defRPr>
+            </a:pPr>
+            <a:r>
+              <a:t>LLM = Large Language Model — Modelo de Linguagem de Grande Escala</a:t>
+            </a:r>
+          </a:p>
+        </p:txBody>
+      </p:sp>
     </p:spTree>
   </p:cSld>
   <p:clrMapOvr>
@@ -9089,6 +9125,42 @@
         </p:nvSpPr>
         <p:spPr>
           <a:xfrm>
+            <a:off x="274320" y="6035040"/>
+            <a:ext cx="11612880" cy="320040"/>
+          </a:xfrm>
+          <a:prstGeom prst="rect">
+            <a:avLst/>
+          </a:prstGeom>
+          <a:noFill/>
+        </p:spPr>
+        <p:txBody>
+          <a:bodyPr wrap="square">
+            <a:spAutoFit/>
+          </a:bodyPr>
+          <a:lstStyle/>
+          <a:p>
+            <a:pPr algn="l">
+              <a:defRPr sz="900" b="0">
+                <a:solidFill>
+                  <a:srgbClr val="2980B9"/>
+                </a:solidFill>
+                <a:latin typeface="Segoe UI"/>
+              </a:defRPr>
+            </a:pPr>
+            <a:r>
+              <a:t>HITL = Human-in-the-Loop — Humano no Ciclo (pontos de aprovação humana em ações críticas)</a:t>
+            </a:r>
+          </a:p>
+        </p:txBody>
+      </p:sp>
+      <p:sp>
+        <p:nvSpPr>
+          <p:cNvPr id="8" name="TextBox 7"/>
+          <p:cNvSpPr txBox="1"/>
+          <p:nvPr/>
+        </p:nvSpPr>
+        <p:spPr>
+          <a:xfrm>
             <a:off x="274320" y="6400800"/>
             <a:ext cx="6400800" cy="365760"/>
           </a:xfrm>
@@ -9119,7 +9191,7 @@
       </p:sp>
       <p:sp>
         <p:nvSpPr>
-          <p:cNvPr id="8" name="TextBox 7"/>
+          <p:cNvPr id="9" name="TextBox 8"/>
           <p:cNvSpPr txBox="1"/>
           <p:nvPr/>
         </p:nvSpPr>
@@ -9613,6 +9685,42 @@
         </p:nvSpPr>
         <p:spPr>
           <a:xfrm>
+            <a:off x="274320" y="6035040"/>
+            <a:ext cx="11612880" cy="320040"/>
+          </a:xfrm>
+          <a:prstGeom prst="rect">
+            <a:avLst/>
+          </a:prstGeom>
+          <a:noFill/>
+        </p:spPr>
+        <p:txBody>
+          <a:bodyPr wrap="square">
+            <a:spAutoFit/>
+          </a:bodyPr>
+          <a:lstStyle/>
+          <a:p>
+            <a:pPr algn="l">
+              <a:defRPr sz="900" b="0">
+                <a:solidFill>
+                  <a:srgbClr val="2980B9"/>
+                </a:solidFill>
+                <a:latin typeface="Segoe UI"/>
+              </a:defRPr>
+            </a:pPr>
+            <a:r>
+              <a:t>ACI = Agent-Computer Interface — Interface Agente-Computador (design das tools; análoga à HCI para humanos)</a:t>
+            </a:r>
+          </a:p>
+        </p:txBody>
+      </p:sp>
+      <p:sp>
+        <p:nvSpPr>
+          <p:cNvPr id="8" name="TextBox 7"/>
+          <p:cNvSpPr txBox="1"/>
+          <p:nvPr/>
+        </p:nvSpPr>
+        <p:spPr>
+          <a:xfrm>
             <a:off x="274320" y="6400800"/>
             <a:ext cx="6400800" cy="365760"/>
           </a:xfrm>
@@ -9643,7 +9751,7 @@
       </p:sp>
       <p:sp>
         <p:nvSpPr>
-          <p:cNvPr id="8" name="TextBox 7"/>
+          <p:cNvPr id="9" name="TextBox 8"/>
           <p:cNvSpPr txBox="1"/>
           <p:nvPr/>
         </p:nvSpPr>
@@ -10055,6 +10163,42 @@
         </p:nvSpPr>
         <p:spPr>
           <a:xfrm>
+            <a:off x="274320" y="6035040"/>
+            <a:ext cx="11612880" cy="320040"/>
+          </a:xfrm>
+          <a:prstGeom prst="rect">
+            <a:avLst/>
+          </a:prstGeom>
+          <a:noFill/>
+        </p:spPr>
+        <p:txBody>
+          <a:bodyPr wrap="square">
+            <a:spAutoFit/>
+          </a:bodyPr>
+          <a:lstStyle/>
+          <a:p>
+            <a:pPr algn="l">
+              <a:defRPr sz="900" b="0">
+                <a:solidFill>
+                  <a:srgbClr val="2980B9"/>
+                </a:solidFill>
+                <a:latin typeface="Segoe UI"/>
+              </a:defRPr>
+            </a:pPr>
+            <a:r>
+              <a:t>RAG = Retrieval-Augmented Generation — Geração Aumentada por Recuperação</a:t>
+            </a:r>
+          </a:p>
+        </p:txBody>
+      </p:sp>
+      <p:sp>
+        <p:nvSpPr>
+          <p:cNvPr id="8" name="TextBox 7"/>
+          <p:cNvSpPr txBox="1"/>
+          <p:nvPr/>
+        </p:nvSpPr>
+        <p:spPr>
+          <a:xfrm>
             <a:off x="274320" y="6400800"/>
             <a:ext cx="6400800" cy="365760"/>
           </a:xfrm>
@@ -10085,7 +10229,7 @@
       </p:sp>
       <p:sp>
         <p:nvSpPr>
-          <p:cNvPr id="8" name="TextBox 7"/>
+          <p:cNvPr id="9" name="TextBox 8"/>
           <p:cNvSpPr txBox="1"/>
           <p:nvPr/>
         </p:nvSpPr>
@@ -11426,6 +11570,42 @@
         </p:nvSpPr>
         <p:spPr>
           <a:xfrm>
+            <a:off x="274320" y="6035040"/>
+            <a:ext cx="11612880" cy="320040"/>
+          </a:xfrm>
+          <a:prstGeom prst="rect">
+            <a:avLst/>
+          </a:prstGeom>
+          <a:noFill/>
+        </p:spPr>
+        <p:txBody>
+          <a:bodyPr wrap="square">
+            <a:spAutoFit/>
+          </a:bodyPr>
+          <a:lstStyle/>
+          <a:p>
+            <a:pPr algn="l">
+              <a:defRPr sz="900" b="0">
+                <a:solidFill>
+                  <a:srgbClr val="2980B9"/>
+                </a:solidFill>
+                <a:latin typeface="Segoe UI"/>
+              </a:defRPr>
+            </a:pPr>
+            <a:r>
+              <a:t>HCI = Human-Computer Interface — Interface Humano-Computador  ·  SWE-bench = Software Engineering Benchmark — benchmark de issues reais do GitHub</a:t>
+            </a:r>
+          </a:p>
+        </p:txBody>
+      </p:sp>
+      <p:sp>
+        <p:nvSpPr>
+          <p:cNvPr id="8" name="TextBox 7"/>
+          <p:cNvSpPr txBox="1"/>
+          <p:nvPr/>
+        </p:nvSpPr>
+        <p:spPr>
+          <a:xfrm>
             <a:off x="274320" y="6400800"/>
             <a:ext cx="6400800" cy="365760"/>
           </a:xfrm>
@@ -11456,7 +11636,7 @@
       </p:sp>
       <p:sp>
         <p:nvSpPr>
-          <p:cNvPr id="8" name="TextBox 7"/>
+          <p:cNvPr id="9" name="TextBox 8"/>
           <p:cNvSpPr txBox="1"/>
           <p:nvPr/>
         </p:nvSpPr>
@@ -12729,6 +12909,42 @@
         </p:nvSpPr>
         <p:spPr>
           <a:xfrm>
+            <a:off x="274320" y="6035040"/>
+            <a:ext cx="11612880" cy="320040"/>
+          </a:xfrm>
+          <a:prstGeom prst="rect">
+            <a:avLst/>
+          </a:prstGeom>
+          <a:noFill/>
+        </p:spPr>
+        <p:txBody>
+          <a:bodyPr wrap="square">
+            <a:spAutoFit/>
+          </a:bodyPr>
+          <a:lstStyle/>
+          <a:p>
+            <a:pPr algn="l">
+              <a:defRPr sz="900" b="0">
+                <a:solidFill>
+                  <a:srgbClr val="2980B9"/>
+                </a:solidFill>
+                <a:latin typeface="Segoe UI"/>
+              </a:defRPr>
+            </a:pPr>
+            <a:r>
+              <a:t>ReAct = Reasoning and Acting — padrão onde o agente intercala Thought, Action e Observation em loop</a:t>
+            </a:r>
+          </a:p>
+        </p:txBody>
+      </p:sp>
+      <p:sp>
+        <p:nvSpPr>
+          <p:cNvPr id="8" name="TextBox 7"/>
+          <p:cNvSpPr txBox="1"/>
+          <p:nvPr/>
+        </p:nvSpPr>
+        <p:spPr>
+          <a:xfrm>
             <a:off x="274320" y="6400800"/>
             <a:ext cx="6400800" cy="365760"/>
           </a:xfrm>
@@ -12759,7 +12975,7 @@
       </p:sp>
       <p:sp>
         <p:nvSpPr>
-          <p:cNvPr id="8" name="TextBox 7"/>
+          <p:cNvPr id="9" name="TextBox 8"/>
           <p:cNvSpPr txBox="1"/>
           <p:nvPr/>
         </p:nvSpPr>
@@ -16669,6 +16885,42 @@
         </p:nvSpPr>
         <p:spPr>
           <a:xfrm>
+            <a:off x="274320" y="6035040"/>
+            <a:ext cx="11612880" cy="320040"/>
+          </a:xfrm>
+          <a:prstGeom prst="rect">
+            <a:avLst/>
+          </a:prstGeom>
+          <a:noFill/>
+        </p:spPr>
+        <p:txBody>
+          <a:bodyPr wrap="square">
+            <a:spAutoFit/>
+          </a:bodyPr>
+          <a:lstStyle/>
+          <a:p>
+            <a:pPr algn="l">
+              <a:defRPr sz="900" b="0">
+                <a:solidFill>
+                  <a:srgbClr val="2980B9"/>
+                </a:solidFill>
+                <a:latin typeface="Segoe UI"/>
+              </a:defRPr>
+            </a:pPr>
+            <a:r>
+              <a:t>MCP = Model Context Protocol — Protocolo de Contexto de Modelo  ·  AgentOps = Agent Operations — operação e monitoramento de agentes</a:t>
+            </a:r>
+          </a:p>
+        </p:txBody>
+      </p:sp>
+      <p:sp>
+        <p:nvSpPr>
+          <p:cNvPr id="8" name="TextBox 7"/>
+          <p:cNvSpPr txBox="1"/>
+          <p:nvPr/>
+        </p:nvSpPr>
+        <p:spPr>
+          <a:xfrm>
             <a:off x="274320" y="6400800"/>
             <a:ext cx="6400800" cy="365760"/>
           </a:xfrm>
@@ -16699,7 +16951,7 @@
       </p:sp>
       <p:sp>
         <p:nvSpPr>
-          <p:cNvPr id="8" name="TextBox 7"/>
+          <p:cNvPr id="9" name="TextBox 8"/>
           <p:cNvSpPr txBox="1"/>
           <p:nvPr/>
         </p:nvSpPr>
@@ -28195,7 +28447,7 @@
               </a:defRPr>
             </a:pPr>
             <a:r>
-              <a:t>ETHAGT04 — Reasoning &amp; Planning (evolução do ReAct)</a:t>
+              <a:t>ETHAGT04 — Reasoning &amp; Planning (Reflexion, ToT, LATS)</a:t>
             </a:r>
           </a:p>
           <a:p>
@@ -28299,6 +28551,42 @@
       <p:sp>
         <p:nvSpPr>
           <p:cNvPr id="7" name="TextBox 6"/>
+          <p:cNvSpPr txBox="1"/>
+          <p:nvPr/>
+        </p:nvSpPr>
+        <p:spPr>
+          <a:xfrm>
+            <a:off x="274320" y="6035040"/>
+            <a:ext cx="11612880" cy="320040"/>
+          </a:xfrm>
+          <a:prstGeom prst="rect">
+            <a:avLst/>
+          </a:prstGeom>
+          <a:noFill/>
+        </p:spPr>
+        <p:txBody>
+          <a:bodyPr wrap="square">
+            <a:spAutoFit/>
+          </a:bodyPr>
+          <a:lstStyle/>
+          <a:p>
+            <a:pPr algn="l">
+              <a:defRPr sz="900" b="0">
+                <a:solidFill>
+                  <a:srgbClr val="2980B9"/>
+                </a:solidFill>
+                <a:latin typeface="Segoe UI"/>
+              </a:defRPr>
+            </a:pPr>
+            <a:r>
+              <a:t>LATS = Language Agent Tree Search — Busca em Árvore com LLM (combina MCTS com LLM para explorar ações)</a:t>
+            </a:r>
+          </a:p>
+        </p:txBody>
+      </p:sp>
+      <p:sp>
+        <p:nvSpPr>
+          <p:cNvPr id="8" name="TextBox 7"/>
           <p:cNvSpPr txBox="1"/>
           <p:nvPr/>
         </p:nvSpPr>
@@ -28334,7 +28622,7 @@
       </p:sp>
       <p:sp>
         <p:nvSpPr>
-          <p:cNvPr id="8" name="TextBox 7"/>
+          <p:cNvPr id="9" name="TextBox 8"/>
           <p:cNvSpPr txBox="1"/>
           <p:nvPr/>
         </p:nvSpPr>
@@ -30142,6 +30430,42 @@
         </p:nvSpPr>
         <p:spPr>
           <a:xfrm>
+            <a:off x="274320" y="6035040"/>
+            <a:ext cx="11612880" cy="320040"/>
+          </a:xfrm>
+          <a:prstGeom prst="rect">
+            <a:avLst/>
+          </a:prstGeom>
+          <a:noFill/>
+        </p:spPr>
+        <p:txBody>
+          <a:bodyPr wrap="square">
+            <a:spAutoFit/>
+          </a:bodyPr>
+          <a:lstStyle/>
+          <a:p>
+            <a:pPr algn="l">
+              <a:defRPr sz="900" b="0">
+                <a:solidFill>
+                  <a:srgbClr val="2980B9"/>
+                </a:solidFill>
+                <a:latin typeface="Segoe UI"/>
+              </a:defRPr>
+            </a:pPr>
+            <a:r>
+              <a:t>CoT = Chain-of-Thought — Cadeia de Pensamento  ·  ToT = Tree of Thoughts — Árvore de Pensamentos</a:t>
+            </a:r>
+          </a:p>
+        </p:txBody>
+      </p:sp>
+      <p:sp>
+        <p:nvSpPr>
+          <p:cNvPr id="8" name="TextBox 7"/>
+          <p:cNvSpPr txBox="1"/>
+          <p:nvPr/>
+        </p:nvSpPr>
+        <p:spPr>
+          <a:xfrm>
             <a:off x="274320" y="6400800"/>
             <a:ext cx="6400800" cy="365760"/>
           </a:xfrm>
@@ -30172,7 +30496,7 @@
       </p:sp>
       <p:sp>
         <p:nvSpPr>
-          <p:cNvPr id="8" name="TextBox 7"/>
+          <p:cNvPr id="9" name="TextBox 8"/>
           <p:cNvSpPr txBox="1"/>
           <p:nvPr/>
         </p:nvSpPr>

</xml_diff>